<commit_message>
docs(pptx): update FinOps deck for the web config manager
Slide 23 (Adaptability) and slide 10 (Security) described the retired
single-admin local Python desktop tool. Updated to the deployed web console:
OIDC SSO + RBAC, multi-environment, optimistic-locked atomic edits, audit log,
and write-only BYOK with Vault/AWS/Azure/GCP key managers. Surgical text-run
edits via python-pptx; layout and all 29 slides preserved.

Co-Authored-By: Claude Opus 4.8 <noreply@anthropic.com>
</commit_message>
<xml_diff>
--- a/docs/Freerouter-FinOps-Presentation.pptx
+++ b/docs/Freerouter-FinOps-Presentation.pptx
@@ -4798,7 +4798,7 @@
                 </a:solidFill>
                 <a:latin typeface="Calibri"/>
               </a:rPr>
-              <a:t>BYOK keystore lives in a 0600 per-user file, never in JSON config or .env. Config Manager auth uses PBKDF2-HMAC-SHA256 (200k iters).</a:t>
+              <a:t>BYOK keys are accepted write-only and encrypted at rest (or kept in your key manager: Vault / AWS / Azure / GCP). The web Config Manager authenticates via OIDC SSO with role-based access.</a:t>
             </a:r>
           </a:p>
         </p:txBody>
@@ -15088,7 +15088,7 @@
                 </a:solidFill>
                 <a:latin typeface="Calibri"/>
               </a:rPr>
-              <a:t>An optional desktop configuration manager lets platform admins update budgets, rules, providers, pricing, and environment variables - without opening a terminal, editing JSON, or filing an engineering ticket.</a:t>
+              <a:t>An optional web configuration manager lets platform admins update budgets, rules, providers, pricing, BYOK keys, and environment variables across multiple environments - without editing JSON or filing an engineering ticket.</a:t>
             </a:r>
           </a:p>
         </p:txBody>
@@ -15193,7 +15193,7 @@
                 </a:solidFill>
                 <a:latin typeface="Calibri"/>
               </a:rPr>
-              <a:t>A separate desktop app, never bundled with the router. Adopt it, ignore it, or remove it - the platform behaves identically either way.</a:t>
+              <a:t>A separate web app, never bundled with the router. Adopt it, ignore it, or remove it - the platform behaves identically either way.</a:t>
             </a:r>
           </a:p>
         </p:txBody>
@@ -15307,7 +15307,7 @@
                 </a:solidFill>
                 <a:latin typeface="Calibri"/>
               </a:rPr>
-              <a:t>Admin-only, key-protected</a:t>
+              <a:t>SSO + role-based access</a:t>
             </a:r>
           </a:p>
         </p:txBody>
@@ -15342,7 +15342,7 @@
                 </a:solidFill>
                 <a:latin typeface="Calibri"/>
               </a:rPr>
-              <a:t>Single-admin access secured by a generated key with a salted, hashed digest stored locally. No key, no GUI.</a:t>
+              <a:t>Multi-user access through your OIDC identity provider; group-to-role mapping grants admins write access and everyone else read-only. Sessions ride in signed, httpOnly cookies.</a:t>
             </a:r>
           </a:p>
         </p:txBody>
@@ -15491,7 +15491,7 @@
                 </a:solidFill>
                 <a:latin typeface="Calibri"/>
               </a:rPr>
-              <a:t>Every save runs the same structural checks the runtime uses; bad inputs are rejected before any file is written.</a:t>
+              <a:t>Every save runs the same structural checks the runtime uses and uses optimistic locking, so concurrent admin edits never clobber each other; bad inputs are rejected before any file is written.</a:t>
             </a:r>
           </a:p>
         </p:txBody>
@@ -15605,7 +15605,7 @@
                 </a:solidFill>
                 <a:latin typeface="Calibri"/>
               </a:rPr>
-              <a:t>Local-only, cross-platform</a:t>
+              <a:t>Multi-environment &amp; audited</a:t>
             </a:r>
           </a:p>
         </p:txBody>
@@ -15640,7 +15640,7 @@
                 </a:solidFill>
                 <a:latin typeface="Calibri"/>
               </a:rPr>
-              <a:t>Runs on Linux, macOS, and Windows. No network surface, no listening port - purely a file editor with guard rails.</a:t>
+              <a:t>Manage dev, staging, and production from one console. Every change is recorded in an audit log - who changed what, when, and in which environment.</a:t>
             </a:r>
           </a:p>
         </p:txBody>

</xml_diff>